<commit_message>
minor tweak to presentation
</commit_message>
<xml_diff>
--- a/presentations/Pipeline Accidents Presentation v0.pptx
+++ b/presentations/Pipeline Accidents Presentation v0.pptx
@@ -4348,14 +4348,14 @@
           <p:nvPr>
             <p:extLst>
               <p:ext uri="{D42A27DB-BD31-4B8C-83A1-F6EECF244321}">
-                <p14:modId xmlns:p14="http://schemas.microsoft.com/office/powerpoint/2010/main" val="2814815693"/>
+                <p14:modId xmlns:p14="http://schemas.microsoft.com/office/powerpoint/2010/main" val="2773062411"/>
               </p:ext>
             </p:extLst>
           </p:nvPr>
         </p:nvGraphicFramePr>
         <p:xfrm>
           <a:off x="348342" y="1694803"/>
-          <a:ext cx="11408226" cy="3153406"/>
+          <a:ext cx="11408226" cy="3061966"/>
         </p:xfrm>
         <a:graphic>
           <a:graphicData uri="http://schemas.openxmlformats.org/drawingml/2006/table">
@@ -4556,7 +4556,25 @@
                           </a:solidFill>
                           <a:latin typeface="IBM Plex Sans Condensed" panose="020B0506050203000203" pitchFamily="34" charset="77"/>
                         </a:rPr>
-                        <a:t>2.1 Prioritize the commodity column as their properties (sweet vs. sour, heavy vs light) are the basis of this analysis. </a:t>
+                        <a:t>2.1 Prioritize the commodity column as their properties (sweet vs. sour, heavy vs light) are the basis of this analysis. Map these properties to binary columns using string extrapolation. E.g., “Heavy </a:t>
+                      </a:r>
+                      <a:r>
+                        <a:rPr lang="en-US" sz="1100" dirty="0" err="1">
+                          <a:solidFill>
+                            <a:schemeClr val="tx1"/>
+                          </a:solidFill>
+                          <a:latin typeface="IBM Plex Sans Condensed" panose="020B0506050203000203" pitchFamily="34" charset="77"/>
+                        </a:rPr>
+                        <a:t>Louisana</a:t>
+                      </a:r>
+                      <a:r>
+                        <a:rPr lang="en-US" sz="1100" dirty="0">
+                          <a:solidFill>
+                            <a:schemeClr val="tx1"/>
+                          </a:solidFill>
+                          <a:latin typeface="IBM Plex Sans Condensed" panose="020B0506050203000203" pitchFamily="34" charset="77"/>
+                        </a:rPr>
+                        <a:t> Sweet” would mark a 1 in the “heavy” and “sweet” columns. These properties were only given for a tiny portion (~45/1355) of the records. </a:t>
                       </a:r>
                     </a:p>
                   </a:txBody>
@@ -4570,7 +4588,7 @@
                   </a:ext>
                 </a:extLst>
               </a:tr>
-              <a:tr h="341598">
+              <a:tr h="285764">
                 <a:tc>
                   <a:txBody>
                     <a:bodyPr/>
@@ -4600,69 +4618,7 @@
                           </a:solidFill>
                           <a:latin typeface="IBM Plex Sans Condensed" panose="020B0506050203000203" pitchFamily="34" charset="77"/>
                         </a:rPr>
-                        <a:t>2.2 Map these properties to binary columns using string extrapolation. E.g., “Heavy </a:t>
-                      </a:r>
-                      <a:r>
-                        <a:rPr lang="en-US" sz="1100" dirty="0" err="1">
-                          <a:solidFill>
-                            <a:schemeClr val="tx1"/>
-                          </a:solidFill>
-                          <a:latin typeface="IBM Plex Sans Condensed" panose="020B0506050203000203" pitchFamily="34" charset="77"/>
-                        </a:rPr>
-                        <a:t>Louisana</a:t>
-                      </a:r>
-                      <a:r>
-                        <a:rPr lang="en-US" sz="1100" dirty="0">
-                          <a:solidFill>
-                            <a:schemeClr val="tx1"/>
-                          </a:solidFill>
-                          <a:latin typeface="IBM Plex Sans Condensed" panose="020B0506050203000203" pitchFamily="34" charset="77"/>
-                        </a:rPr>
-                        <a:t> Sweet” would mark a 1 in the “heavy” and “sweet” columns. These properties were only given for a tiny portion (~45/1355) of the records. </a:t>
-                      </a:r>
-                    </a:p>
-                  </a:txBody>
-                  <a:tcPr>
-                    <a:noFill/>
-                  </a:tcPr>
-                </a:tc>
-                <a:extLst>
-                  <a:ext uri="{0D108BD9-81ED-4DB2-BD59-A6C34878D82A}">
-                    <a16:rowId xmlns:a16="http://schemas.microsoft.com/office/drawing/2014/main" val="2774700380"/>
-                  </a:ext>
-                </a:extLst>
-              </a:tr>
-              <a:tr h="285764">
-                <a:tc>
-                  <a:txBody>
-                    <a:bodyPr/>
-                    <a:lstStyle/>
-                    <a:p>
-                      <a:endParaRPr lang="en-US" sz="1100" dirty="0">
-                        <a:solidFill>
-                          <a:schemeClr val="tx1"/>
-                        </a:solidFill>
-                        <a:latin typeface="IBM Plex Sans Condensed" panose="020B0506050203000203" pitchFamily="34" charset="77"/>
-                      </a:endParaRPr>
-                    </a:p>
-                  </a:txBody>
-                  <a:tcPr>
-                    <a:noFill/>
-                  </a:tcPr>
-                </a:tc>
-                <a:tc>
-                  <a:txBody>
-                    <a:bodyPr/>
-                    <a:lstStyle/>
-                    <a:p>
-                      <a:r>
-                        <a:rPr lang="en-US" sz="1100" dirty="0">
-                          <a:solidFill>
-                            <a:schemeClr val="tx1"/>
-                          </a:solidFill>
-                          <a:latin typeface="IBM Plex Sans Condensed" panose="020B0506050203000203" pitchFamily="34" charset="77"/>
-                        </a:rPr>
-                        <a:t>2.3 Identify and fill in the general cause of the incident using logic from the corresponding data dictionary. </a:t>
+                        <a:t>2.2 Identify and fill in the general cause of the incident using logic from the corresponding data dictionary. </a:t>
                       </a:r>
                     </a:p>
                   </a:txBody>
@@ -4711,7 +4667,7 @@
                           </a:solidFill>
                           <a:latin typeface="IBM Plex Sans Condensed" panose="020B0506050203000203" pitchFamily="34" charset="77"/>
                         </a:rPr>
-                        <a:t>2.4 Clean the remaining columns using a similar process to that for dataset A / Approach #1. </a:t>
+                        <a:t>2.3 Clean the remaining columns using a similar process to that for dataset A / Approach #1. </a:t>
                       </a:r>
                     </a:p>
                   </a:txBody>
@@ -5037,7 +4993,7 @@
           <p:nvPr>
             <p:extLst>
               <p:ext uri="{D42A27DB-BD31-4B8C-83A1-F6EECF244321}">
-                <p14:modId xmlns:p14="http://schemas.microsoft.com/office/powerpoint/2010/main" val="4038507880"/>
+                <p14:modId xmlns:p14="http://schemas.microsoft.com/office/powerpoint/2010/main" val="1852076606"/>
               </p:ext>
             </p:extLst>
           </p:nvPr>
@@ -5106,7 +5062,25 @@
                           </a:solidFill>
                           <a:latin typeface="IBM Plex Sans Condensed" panose="020B0506050203000203" pitchFamily="34" charset="77"/>
                         </a:rPr>
-                        <a:t>The majority of the steps from 2.3 - onwards were performed and iterated upon in an attempt to salvage the approach. Ultimately, the minimal number of records (~45) with property-specific information on crude oil limited the extent of this analysis. </a:t>
+                        <a:t>The majority of the steps </a:t>
+                      </a:r>
+                      <a:r>
+                        <a:rPr lang="en-US" sz="1100" b="0">
+                          <a:solidFill>
+                            <a:schemeClr val="tx1"/>
+                          </a:solidFill>
+                          <a:latin typeface="IBM Plex Sans Condensed" panose="020B0506050203000203" pitchFamily="34" charset="77"/>
+                        </a:rPr>
+                        <a:t>from 2.2 </a:t>
+                      </a:r>
+                      <a:r>
+                        <a:rPr lang="en-US" sz="1100" b="0" dirty="0">
+                          <a:solidFill>
+                            <a:schemeClr val="tx1"/>
+                          </a:solidFill>
+                          <a:latin typeface="IBM Plex Sans Condensed" panose="020B0506050203000203" pitchFamily="34" charset="77"/>
+                        </a:rPr>
+                        <a:t>- onwards were performed and iterated upon in an attempt to salvage the approach. Ultimately, the minimal number of records (~45) with property-specific information on crude oil limited the extent of this analysis. </a:t>
                       </a:r>
                     </a:p>
                   </a:txBody>
@@ -23578,7 +23552,7 @@
                 </a:solidFill>
                 <a:latin typeface="IBM Plex Sans Condensed" panose="020B0506050203000203" pitchFamily="34" charset="77"/>
               </a:rPr>
-              <a:t>DATASET COLLECTION</a:t>
+              <a:t>DATASET SELECTION</a:t>
             </a:r>
           </a:p>
           <a:p>

</xml_diff>